<commit_message>
Correct team roles everywhere to match weekly-report evidence and git history
</commit_message>
<xml_diff>
--- a/docs/AdInsight_Final_Presentation.pptx
+++ b/docs/AdInsight_Final_Presentation.pptx
@@ -4941,7 +4941,7 @@
                 </a:solidFill>
                 <a:latin typeface="Calibri"/>
               </a:rPr>
-              <a:t>Engineering · Data &amp; Eval</a:t>
+              <a:t>Engineering · Classifier · App &amp; Extension</a:t>
             </a:r>
           </a:p>
         </p:txBody>
@@ -5019,7 +5019,7 @@
                 </a:solidFill>
                 <a:latin typeface="Calibri"/>
               </a:rPr>
-              <a:t>Architecture · OCR/VLM · Agents</a:t>
+              <a:t>Architecture · ASR/VLM · Review Layer</a:t>
             </a:r>
           </a:p>
         </p:txBody>
@@ -5097,7 +5097,7 @@
                 </a:solidFill>
                 <a:latin typeface="Calibri"/>
               </a:rPr>
-              <a:t>Review Insights · Evidence</a:t>
+              <a:t>Data &amp; Annotation · Hyperopt Tuning</a:t>
             </a:r>
           </a:p>
         </p:txBody>
@@ -5175,7 +5175,7 @@
                 </a:solidFill>
                 <a:latin typeface="Calibri"/>
               </a:rPr>
-              <a:t>App · Browser Extension</a:t>
+              <a:t>Data Pipeline · Baseline Model</a:t>
             </a:r>
           </a:p>
         </p:txBody>

</xml_diff>

<commit_message>
Update final presentation deck to reflect the review-layer removal
The review-insight layer was removed from the build (broken retrieval,
no time to fix before the demo), so the deck now says it was prototyped
but not shipped: team-role line, architecture slide + speaker notes,
ethics slide, and future-work slide. Test count updated to 186
(130 Python + 56 JS).

Co-Authored-By: Claude Fable 5 <noreply@anthropic.com>
</commit_message>
<xml_diff>
--- a/docs/AdInsight_Final_Presentation.pptx
+++ b/docs/AdInsight_Final_Presentation.pptx
@@ -804,7 +804,7 @@
           <a:p/>
           <a:p>
             <a:r>
-              <a:t>The pipeline has four steps. Read: for image ads, a vision-language model transcribes the ad — and it's restricted by prompt to transcription only, it may not name tactics or judge — with fully local OCR as the offline fallback. Classify: a fine-tuned DistilBERT, eight classes, with sliding windows so long ads still get scored end to end. Explain: every finding is badged with its evidence — either "model pick" with a confidence, or "phrase found," a trigger phrase from our labeling guidelines literally present in the ad. And below sixty percent confidence with no phrase, the system says "not sure" instead of guessing. Check: a review layer searches independent sources — advertiser-owned domains excluded, affiliate content flagged. And the whole thing is held together by 183 automated tests. [Target: 3:00]</a:t>
+              <a:t>The pipeline has four steps. Read: for image ads, a vision-language model transcribes the ad — and it's restricted by prompt to transcription only, it may not name tactics or judge — with fully local OCR as the offline fallback. Classify: a fine-tuned DistilBERT, eight classes, with sliding windows so long ads still get scored end to end. Explain: every finding is badged with its evidence — either "model pick" with a confidence, or "phrase found," a trigger phrase from our labeling guidelines literally present in the ad. And below sixty percent confidence with no phrase, the system says "not sure" instead of guessing. Check: we prototyped a review layer that searched independent sources, but its retrieval was not reliable enough to ship, so we removed it from the final build. The whole thing is held together by 186 automated tests. [Target: 3:00]</a:t>
             </a:r>
           </a:p>
         </p:txBody>
@@ -5019,7 +5019,7 @@
                 </a:solidFill>
                 <a:latin typeface="Calibri"/>
               </a:rPr>
-              <a:t>Architecture · ASR/VLM · Review Layer</a:t>
+              <a:t>Architecture · ASR/VLM · VLM Extraction</a:t>
             </a:r>
           </a:p>
         </p:txBody>
@@ -5651,7 +5651,7 @@
                 </a:solidFill>
                 <a:latin typeface="Calibri"/>
               </a:rPr>
-              <a:t>Screenshots can contain more than the ad. The RapidOCR path runs fully on-device; VLM and review search leave the device only when API keys are configured — and that boundary must be disclosed to users. Nothing is retained.</a:t>
+              <a:t>Screenshots can contain more than the ad. The RapidOCR path runs fully on-device; the VLM path leaves the device only when an API key is configured — and that boundary must be disclosed to users. Nothing is retained.</a:t>
             </a:r>
           </a:p>
         </p:txBody>
@@ -5775,7 +5775,7 @@
                 </a:solidFill>
                 <a:latin typeface="Calibri"/>
               </a:rPr>
-              <a:t>High-confidence errors happen ("Urgency, 98%", no deadline). Mitigations: the &lt;60% guard prefers silence to false alarms; every finding carries checkable evidence; the review layer excludes advertiser-owned sources. AdInsight supports judgment — it never replaces it.</a:t>
+              <a:t>High-confidence errors happen ("Urgency, 98%", no deadline). Mitigations: the &lt;60% guard prefers silence to false alarms; every finding carries checkable evidence the user can verify against the ad itself. AdInsight supports judgment — it never replaces it.</a:t>
             </a:r>
           </a:p>
         </p:txBody>
@@ -6368,7 +6368,7 @@
                 </a:solidFill>
                 <a:latin typeface="Calibri"/>
               </a:rPr>
-              <a:t>Multi-label classification head · real-ad training data for uncovered genres (income claims) · a larger usability cohort · hardening the review layer's retrieval.</a:t>
+              <a:t>Multi-label classification head · real-ad training data for uncovered genres (income claims) · a larger usability cohort · rebuilding the review-insight layer with retrieval reliable enough to ship.</a:t>
             </a:r>
           </a:p>
         </p:txBody>
@@ -8273,7 +8273,7 @@
                 </a:solidFill>
                 <a:latin typeface="Calibri"/>
               </a:rPr>
-              <a:t>Review layer: independent-source web search with advertiser-owned domains excluded and affiliate content flagged; falls back to clearly-badged sample data without API keys.</a:t>
+              <a:t>A review-insight layer (independent-source web search) was prototyped, but its retrieval was not reliable enough to ship — it was removed from the final build.</a:t>
             </a:r>
           </a:p>
         </p:txBody>
@@ -8312,7 +8312,7 @@
                 </a:solidFill>
                 <a:latin typeface="Calibri"/>
               </a:rPr>
-              <a:t>Engineering: 183 automated tests (126 Python + 57 JS) · model ships as 134 MB float16.</a:t>
+              <a:t>Engineering: 186 automated tests (130 Python + 56 JS) · model ships as 134 MB float16.</a:t>
             </a:r>
           </a:p>
         </p:txBody>

</xml_diff>